<commit_message>
Revisionen Abb. 2.3, 2.4, 2.5, 3.1–3.10 (DS 07.10.2026)
- 2.3, 2.5, 3.6, 3.9: Knotenpunkte entfernt, Farben/Pfeile nach Auftrag
- 2.4: Spaltenköpfe kursiv ohne Kasten, Phasen hängend eingerückt, Durchführung mittig
- 3.1: Layout neu, Roadmap/BCR rot, externes Reporting entfällt, Teilpläne aus 3.6
- 3.2: Stand 30.06.2027, PL 2027/VJ 2026, Filter Geschäftsbereich, Gesamtsaldo
- 3.3–3.5: Daten um ein Jahr verschoben, „Stand“; 3.5 Portfolio mit strategischer Relevanz
- 3.7, 3.8: Titel fett wie 3.5, Budget 2028, Varianten Best/Worst Case, Klappen repariert
- 3.10: Startcockpit-Navigation, gestrichelte Kästen entfallen

Rückmeldungen an die Tabelle (revision.py melden) stehen noch aus.

Co-Authored-By: Claude Opus 5.5 <noreply@anthropic.com>
Claude-Session: https://claude.ai/code/session_01EpEBMAph13iBTYADwEZukx
</commit_message>
<xml_diff>
--- a/abbildungen/kap2/Interdependenzen_der_betrieblichen_Teilplaene.pptx
+++ b/abbildungen/kap2/Interdependenzen_der_betrieblichen_Teilplaene.pptx
@@ -4630,13 +4630,10 @@
             </a:avLst>
           </a:prstGeom>
           <a:solidFill>
-            <a:srgbClr val="EFEFEF"/>
+            <a:srgbClr val="C62828"/>
           </a:solidFill>
-          <a:ln w="6350">
-            <a:solidFill>
-              <a:srgbClr val="9A9A9A"/>
-            </a:solidFill>
-            <a:round/>
+          <a:ln>
+            <a:noFill/>
           </a:ln>
         </p:spPr>
         <p:txBody>
@@ -4652,9 +4649,9 @@
               <a:buNone/>
             </a:pPr>
             <a:r>
-              <a:rPr lang="de-DE" sz="600" b="0" i="0">
-                <a:solidFill>
-                  <a:srgbClr val="1A1A1A"/>
+              <a:rPr lang="de-DE" sz="600" b="1" i="0">
+                <a:solidFill>
+                  <a:srgbClr val="FFFFFF"/>
                 </a:solidFill>
                 <a:latin typeface="Arial"/>
               </a:rPr>
@@ -5989,13 +5986,10 @@
             </a:avLst>
           </a:prstGeom>
           <a:solidFill>
-            <a:srgbClr val="CFCFCF"/>
+            <a:srgbClr val="C62828"/>
           </a:solidFill>
-          <a:ln w="6350">
-            <a:solidFill>
-              <a:srgbClr val="8A8A8A"/>
-            </a:solidFill>
-            <a:round/>
+          <a:ln>
+            <a:noFill/>
           </a:ln>
         </p:spPr>
         <p:txBody>
@@ -6011,45 +6005,45 @@
               <a:buNone/>
             </a:pPr>
             <a:r>
-              <a:rPr lang="de-DE" sz="600" b="0" i="0">
-                <a:solidFill>
-                  <a:srgbClr val="1A1A1A"/>
+              <a:rPr lang="de-DE" sz="600" b="1" i="0">
+                <a:solidFill>
+                  <a:srgbClr val="FFFFFF"/>
                 </a:solidFill>
                 <a:latin typeface="Arial"/>
               </a:rPr>
               <a:t>Betriebs-</a:t>
             </a:r>
             <a:br>
-              <a:rPr lang="de-DE" sz="600" b="0" i="0">
-                <a:solidFill>
-                  <a:srgbClr val="1A1A1A"/>
+              <a:rPr lang="de-DE" sz="600" b="1" i="0">
+                <a:solidFill>
+                  <a:srgbClr val="FFFFFF"/>
                 </a:solidFill>
                 <a:latin typeface="Arial"/>
                 <a:cs typeface="Arial"/>
               </a:rPr>
             </a:br>
             <a:r>
-              <a:rPr lang="de-DE" sz="600" b="0" i="0">
-                <a:solidFill>
-                  <a:srgbClr val="1A1A1A"/>
+              <a:rPr lang="de-DE" sz="600" b="1" i="0">
+                <a:solidFill>
+                  <a:srgbClr val="FFFFFF"/>
                 </a:solidFill>
                 <a:latin typeface="Arial"/>
               </a:rPr>
               <a:t>ergebnis-</a:t>
             </a:r>
             <a:br>
-              <a:rPr lang="de-DE" sz="600" b="0" i="0">
-                <a:solidFill>
-                  <a:srgbClr val="1A1A1A"/>
+              <a:rPr lang="de-DE" sz="600" b="1" i="0">
+                <a:solidFill>
+                  <a:srgbClr val="FFFFFF"/>
                 </a:solidFill>
                 <a:latin typeface="Arial"/>
                 <a:cs typeface="Arial"/>
               </a:rPr>
             </a:br>
             <a:r>
-              <a:rPr lang="de-DE" sz="600" b="0" i="0">
-                <a:solidFill>
-                  <a:srgbClr val="1A1A1A"/>
+              <a:rPr lang="de-DE" sz="600" b="1" i="0">
+                <a:solidFill>
+                  <a:srgbClr val="FFFFFF"/>
                 </a:solidFill>
                 <a:latin typeface="Arial"/>
               </a:rPr>
@@ -6229,10 +6223,13 @@
             </a:avLst>
           </a:prstGeom>
           <a:solidFill>
-            <a:srgbClr val="C62828"/>
+            <a:srgbClr val="CFCFCF"/>
           </a:solidFill>
-          <a:ln>
-            <a:noFill/>
+          <a:ln w="6350">
+            <a:solidFill>
+              <a:srgbClr val="8A8A8A"/>
+            </a:solidFill>
+            <a:round/>
           </a:ln>
         </p:spPr>
         <p:txBody>
@@ -6248,27 +6245,27 @@
               <a:buNone/>
             </a:pPr>
             <a:r>
-              <a:rPr lang="de-DE" sz="600" b="1" i="0">
-                <a:solidFill>
-                  <a:srgbClr val="FFFFFF"/>
+              <a:rPr lang="de-DE" sz="600" b="0" i="0">
+                <a:solidFill>
+                  <a:srgbClr val="1A1A1A"/>
                 </a:solidFill>
                 <a:latin typeface="Arial"/>
               </a:rPr>
               <a:t>Kosten-</a:t>
             </a:r>
             <a:br>
-              <a:rPr lang="de-DE" sz="600" b="1" i="0">
-                <a:solidFill>
-                  <a:srgbClr val="FFFFFF"/>
+              <a:rPr lang="de-DE" sz="600" b="0" i="0">
+                <a:solidFill>
+                  <a:srgbClr val="1A1A1A"/>
                 </a:solidFill>
                 <a:latin typeface="Arial"/>
                 <a:cs typeface="Arial"/>
               </a:rPr>
             </a:br>
             <a:r>
-              <a:rPr lang="de-DE" sz="600" b="1" i="0">
-                <a:solidFill>
-                  <a:srgbClr val="FFFFFF"/>
+              <a:rPr lang="de-DE" sz="600" b="0" i="0">
+                <a:solidFill>
+                  <a:srgbClr val="1A1A1A"/>
                 </a:solidFill>
                 <a:latin typeface="Arial"/>
               </a:rPr>
@@ -6683,8 +6680,8 @@
         </p:nvSpPr>
         <p:spPr>
           <a:xfrm>
-            <a:off x="2295000" y="1346400"/>
-            <a:ext cx="0" cy="129600"/>
+            <a:off x="2295000" y="1382400"/>
+            <a:ext cx="0" cy="93600"/>
           </a:xfrm>
           <a:custGeom>
             <a:avLst/>
@@ -6693,12 +6690,12 @@
             <a:cxnLst/>
             <a:rect l="l" t="t" r="r" b="b"/>
             <a:pathLst>
-              <a:path w="0" h="129600">
+              <a:path w="0" h="93600">
                 <a:moveTo>
                   <a:pt x="0" y="0"/>
                 </a:moveTo>
                 <a:lnTo>
-                  <a:pt x="0" y="129600"/>
+                  <a:pt x="0" y="93600"/>
                 </a:lnTo>
               </a:path>
             </a:pathLst>
@@ -6728,8 +6725,8 @@
         </p:nvSpPr>
         <p:spPr>
           <a:xfrm>
-            <a:off x="1548000" y="1346400"/>
-            <a:ext cx="0" cy="360000"/>
+            <a:off x="1548000" y="1382400"/>
+            <a:ext cx="0" cy="324000"/>
           </a:xfrm>
           <a:custGeom>
             <a:avLst/>
@@ -6738,12 +6735,12 @@
             <a:cxnLst/>
             <a:rect l="l" t="t" r="r" b="b"/>
             <a:pathLst>
-              <a:path w="0" h="360000">
+              <a:path w="0" h="324000">
                 <a:moveTo>
                   <a:pt x="0" y="0"/>
                 </a:moveTo>
                 <a:lnTo>
-                  <a:pt x="0" y="360000"/>
+                  <a:pt x="0" y="324000"/>
                 </a:lnTo>
               </a:path>
             </a:pathLst>
@@ -6773,8 +6770,8 @@
         </p:nvSpPr>
         <p:spPr>
           <a:xfrm>
-            <a:off x="990000" y="1346400"/>
-            <a:ext cx="0" cy="705600"/>
+            <a:off x="990000" y="1382400"/>
+            <a:ext cx="0" cy="669600"/>
           </a:xfrm>
           <a:custGeom>
             <a:avLst/>
@@ -6783,12 +6780,12 @@
             <a:cxnLst/>
             <a:rect l="l" t="t" r="r" b="b"/>
             <a:pathLst>
-              <a:path w="0" h="705600">
+              <a:path w="0" h="669600">
                 <a:moveTo>
                   <a:pt x="0" y="0"/>
                 </a:moveTo>
                 <a:lnTo>
-                  <a:pt x="0" y="705600"/>
+                  <a:pt x="0" y="669600"/>
                 </a:lnTo>
               </a:path>
             </a:pathLst>
@@ -6857,51 +6854,6 @@
       <p:sp>
         <p:nvSpPr>
           <p:cNvPr id="66" name="Freeform 65"/>
-          <p:cNvSpPr/>
-          <p:nvPr/>
-        </p:nvSpPr>
-        <p:spPr>
-          <a:xfrm>
-            <a:off x="3362400" y="1346400"/>
-            <a:ext cx="0" cy="475200"/>
-          </a:xfrm>
-          <a:custGeom>
-            <a:avLst/>
-            <a:gdLst/>
-            <a:ahLst/>
-            <a:cxnLst/>
-            <a:rect l="l" t="t" r="r" b="b"/>
-            <a:pathLst>
-              <a:path w="0" h="475200">
-                <a:moveTo>
-                  <a:pt x="0" y="0"/>
-                </a:moveTo>
-                <a:lnTo>
-                  <a:pt x="0" y="475200"/>
-                </a:lnTo>
-              </a:path>
-            </a:pathLst>
-          </a:custGeom>
-          <a:noFill/>
-          <a:ln w="9525">
-            <a:solidFill>
-              <a:srgbClr val="3A3F44"/>
-            </a:solidFill>
-            <a:round/>
-            <a:tailEnd type="triangle" w="med" len="med"/>
-          </a:ln>
-        </p:spPr>
-        <p:txBody>
-          <a:bodyPr rtlCol="0" anchor="ctr"/>
-          <a:lstStyle/>
-          <a:p>
-            <a:pPr algn="ctr"/>
-          </a:p>
-        </p:txBody>
-      </p:sp>
-      <p:sp>
-        <p:nvSpPr>
-          <p:cNvPr id="67" name="Freeform 66"/>
           <p:cNvSpPr/>
           <p:nvPr/>
         </p:nvSpPr>
@@ -6947,7 +6899,7 @@
       </p:sp>
       <p:sp>
         <p:nvSpPr>
-          <p:cNvPr id="68" name="TextBox 67"/>
+          <p:cNvPr id="67" name="TextBox 66"/>
           <p:cNvSpPr txBox="1"/>
           <p:nvPr/>
         </p:nvSpPr>
@@ -6987,7 +6939,7 @@
       </p:sp>
       <p:sp>
         <p:nvSpPr>
-          <p:cNvPr id="69" name="Freeform 68"/>
+          <p:cNvPr id="68" name="Freeform 67"/>
           <p:cNvSpPr/>
           <p:nvPr/>
         </p:nvSpPr>
@@ -7032,7 +6984,7 @@
       </p:sp>
       <p:sp>
         <p:nvSpPr>
-          <p:cNvPr id="70" name="Freeform 69"/>
+          <p:cNvPr id="69" name="Freeform 68"/>
           <p:cNvSpPr/>
           <p:nvPr/>
         </p:nvSpPr>
@@ -7076,7 +7028,7 @@
       </p:sp>
       <p:sp>
         <p:nvSpPr>
-          <p:cNvPr id="71" name="Freeform 70"/>
+          <p:cNvPr id="70" name="Freeform 69"/>
           <p:cNvSpPr/>
           <p:nvPr/>
         </p:nvSpPr>
@@ -7126,7 +7078,7 @@
       </p:sp>
       <p:sp>
         <p:nvSpPr>
-          <p:cNvPr id="72" name="Freeform 71"/>
+          <p:cNvPr id="71" name="Freeform 70"/>
           <p:cNvSpPr/>
           <p:nvPr/>
         </p:nvSpPr>
@@ -7177,7 +7129,7 @@
       </p:sp>
       <p:sp>
         <p:nvSpPr>
-          <p:cNvPr id="73" name="Freeform 72"/>
+          <p:cNvPr id="72" name="Freeform 71"/>
           <p:cNvSpPr/>
           <p:nvPr/>
         </p:nvSpPr>
@@ -7222,7 +7174,7 @@
       </p:sp>
       <p:sp>
         <p:nvSpPr>
-          <p:cNvPr id="74" name="Freeform 73"/>
+          <p:cNvPr id="73" name="Freeform 72"/>
           <p:cNvSpPr/>
           <p:nvPr/>
         </p:nvSpPr>
@@ -7271,7 +7223,7 @@
       </p:sp>
       <p:sp>
         <p:nvSpPr>
-          <p:cNvPr id="75" name="Freeform 74"/>
+          <p:cNvPr id="74" name="Freeform 73"/>
           <p:cNvSpPr/>
           <p:nvPr/>
         </p:nvSpPr>
@@ -7316,7 +7268,7 @@
       </p:sp>
       <p:sp>
         <p:nvSpPr>
-          <p:cNvPr id="76" name="Freeform 75"/>
+          <p:cNvPr id="75" name="Freeform 74"/>
           <p:cNvSpPr/>
           <p:nvPr/>
         </p:nvSpPr>
@@ -7361,7 +7313,7 @@
       </p:sp>
       <p:sp>
         <p:nvSpPr>
-          <p:cNvPr id="77" name="Freeform 76"/>
+          <p:cNvPr id="76" name="Freeform 75"/>
           <p:cNvSpPr/>
           <p:nvPr/>
         </p:nvSpPr>
@@ -7406,7 +7358,7 @@
       </p:sp>
       <p:sp>
         <p:nvSpPr>
-          <p:cNvPr id="78" name="Freeform 77"/>
+          <p:cNvPr id="77" name="Freeform 76"/>
           <p:cNvSpPr/>
           <p:nvPr/>
         </p:nvSpPr>
@@ -7451,7 +7403,7 @@
       </p:sp>
       <p:sp>
         <p:nvSpPr>
-          <p:cNvPr id="79" name="Freeform 78"/>
+          <p:cNvPr id="78" name="Freeform 77"/>
           <p:cNvSpPr/>
           <p:nvPr/>
         </p:nvSpPr>
@@ -7496,7 +7448,7 @@
       </p:sp>
       <p:sp>
         <p:nvSpPr>
-          <p:cNvPr id="80" name="Freeform 79"/>
+          <p:cNvPr id="79" name="Freeform 78"/>
           <p:cNvSpPr/>
           <p:nvPr/>
         </p:nvSpPr>
@@ -7541,7 +7493,7 @@
       </p:sp>
       <p:sp>
         <p:nvSpPr>
-          <p:cNvPr id="81" name="Freeform 80"/>
+          <p:cNvPr id="80" name="Freeform 79"/>
           <p:cNvSpPr/>
           <p:nvPr/>
         </p:nvSpPr>
@@ -7586,7 +7538,7 @@
       </p:sp>
       <p:sp>
         <p:nvSpPr>
-          <p:cNvPr id="82" name="Freeform 81"/>
+          <p:cNvPr id="81" name="Freeform 80"/>
           <p:cNvSpPr/>
           <p:nvPr/>
         </p:nvSpPr>
@@ -7631,7 +7583,7 @@
       </p:sp>
       <p:sp>
         <p:nvSpPr>
-          <p:cNvPr id="83" name="Freeform 82"/>
+          <p:cNvPr id="82" name="Freeform 81"/>
           <p:cNvSpPr/>
           <p:nvPr/>
         </p:nvSpPr>
@@ -7676,7 +7628,7 @@
       </p:sp>
       <p:sp>
         <p:nvSpPr>
-          <p:cNvPr id="84" name="Freeform 83"/>
+          <p:cNvPr id="83" name="Freeform 82"/>
           <p:cNvSpPr/>
           <p:nvPr/>
         </p:nvSpPr>
@@ -7721,7 +7673,7 @@
       </p:sp>
       <p:sp>
         <p:nvSpPr>
-          <p:cNvPr id="85" name="Freeform 84"/>
+          <p:cNvPr id="84" name="Freeform 83"/>
           <p:cNvSpPr/>
           <p:nvPr/>
         </p:nvSpPr>
@@ -7766,7 +7718,7 @@
       </p:sp>
       <p:sp>
         <p:nvSpPr>
-          <p:cNvPr id="86" name="Freeform 85"/>
+          <p:cNvPr id="85" name="Freeform 84"/>
           <p:cNvSpPr/>
           <p:nvPr/>
         </p:nvSpPr>
@@ -7817,7 +7769,7 @@
       </p:sp>
       <p:sp>
         <p:nvSpPr>
-          <p:cNvPr id="87" name="Freeform 86"/>
+          <p:cNvPr id="86" name="Freeform 85"/>
           <p:cNvSpPr/>
           <p:nvPr/>
         </p:nvSpPr>
@@ -7861,7 +7813,7 @@
       </p:sp>
       <p:sp>
         <p:nvSpPr>
-          <p:cNvPr id="88" name="Freeform 87"/>
+          <p:cNvPr id="87" name="Freeform 86"/>
           <p:cNvSpPr/>
           <p:nvPr/>
         </p:nvSpPr>
@@ -7906,36 +7858,7 @@
       </p:sp>
       <p:sp>
         <p:nvSpPr>
-          <p:cNvPr id="89" name="Knoten"/>
-          <p:cNvSpPr/>
-          <p:nvPr/>
-        </p:nvSpPr>
-        <p:spPr>
-          <a:xfrm>
-            <a:off x="5124600" y="1520233"/>
-            <a:ext cx="32400" cy="32400"/>
-          </a:xfrm>
-          <a:prstGeom prst="ellipse">
-            <a:avLst/>
-          </a:prstGeom>
-          <a:solidFill>
-            <a:srgbClr val="3A3F44"/>
-          </a:solidFill>
-          <a:ln>
-            <a:noFill/>
-          </a:ln>
-        </p:spPr>
-        <p:txBody>
-          <a:bodyPr rtlCol="0" anchor="ctr"/>
-          <a:lstStyle/>
-          <a:p>
-            <a:pPr algn="ctr"/>
-          </a:p>
-        </p:txBody>
-      </p:sp>
-      <p:sp>
-        <p:nvSpPr>
-          <p:cNvPr id="90" name="Freeform 89"/>
+          <p:cNvPr id="88" name="Freeform 87"/>
           <p:cNvSpPr/>
           <p:nvPr/>
         </p:nvSpPr>
@@ -7983,7 +7906,7 @@
       </p:sp>
       <p:sp>
         <p:nvSpPr>
-          <p:cNvPr id="91" name="Freeform 90"/>
+          <p:cNvPr id="89" name="Freeform 88"/>
           <p:cNvSpPr/>
           <p:nvPr/>
         </p:nvSpPr>
@@ -8028,36 +7951,7 @@
       </p:sp>
       <p:sp>
         <p:nvSpPr>
-          <p:cNvPr id="92" name="Knoten"/>
-          <p:cNvSpPr/>
-          <p:nvPr/>
-        </p:nvSpPr>
-        <p:spPr>
-          <a:xfrm>
-            <a:off x="5542200" y="2926228"/>
-            <a:ext cx="32400" cy="32400"/>
-          </a:xfrm>
-          <a:prstGeom prst="ellipse">
-            <a:avLst/>
-          </a:prstGeom>
-          <a:solidFill>
-            <a:srgbClr val="3A3F44"/>
-          </a:solidFill>
-          <a:ln>
-            <a:noFill/>
-          </a:ln>
-        </p:spPr>
-        <p:txBody>
-          <a:bodyPr rtlCol="0" anchor="ctr"/>
-          <a:lstStyle/>
-          <a:p>
-            <a:pPr algn="ctr"/>
-          </a:p>
-        </p:txBody>
-      </p:sp>
-      <p:sp>
-        <p:nvSpPr>
-          <p:cNvPr id="93" name="Freeform 92"/>
+          <p:cNvPr id="90" name="Freeform 89"/>
           <p:cNvSpPr/>
           <p:nvPr/>
         </p:nvSpPr>

</xml_diff>